<commit_message>
docs: refleja nube (NVIDIA+Gemini), menu de claves y --probar-api
</commit_message>
<xml_diff>
--- a/docs/manual-g360-textofix.pptx
+++ b/docs/manual-g360-textofix.pptx
@@ -3414,7 +3414,7 @@
                   <a:srgbClr val="E9ECF2"/>
                 </a:solidFill>
               </a:rPr>
-              <a:t>Corrector de texto para Windows · atajo global · corrección offline (Ollama) o por la nube (Gemini)</a:t>
+              <a:t>Corrector de texto para Windows · atajo global · corrección por la nube (NVIDIA o Gemini)</a:t>
             </a:r>
           </a:p>
         </p:txBody>
@@ -5970,7 +5970,7 @@
                   <a:srgbClr val="0B1220"/>
                 </a:solidFill>
               </a:rPr>
-              <a:t>Configurar clave API…</a:t>
+              <a:t>Clave API Gemini… / NVIDIA…</a:t>
             </a:r>
           </a:p>
         </p:txBody>
@@ -7322,7 +7322,7 @@
                   <a:srgbClr val="0B1220"/>
                 </a:solidFill>
               </a:rPr>
-              <a:t>La clave de Gemini</a:t>
+              <a:t>Las claves de API</a:t>
             </a:r>
           </a:p>
         </p:txBody>
@@ -7356,7 +7356,7 @@
                   <a:srgbClr val="2A2E39"/>
                 </a:solidFill>
               </a:rPr>
-              <a:t>Primera vez te la pide la consola, luego vive cifrada en tu perfil.</a:t>
+              <a:t>Si no hay ninguna, la consola las pide la primera vez; al guardarlas se verifican con una llamada real.</a:t>
             </a:r>
           </a:p>
         </p:txBody>
@@ -7502,7 +7502,7 @@
                   <a:srgbClr val="0B1220"/>
                 </a:solidFill>
               </a:rPr>
-              <a:t>El almacén cifrado de Windows (DPAPI) — %APPDATA%\g360-textofix\clave.dat</a:t>
+              <a:t>El almacén cifrado de Windows (DPAPI) — clave.dat (Gemini) y clave_nim.dat (NVIDIA)</a:t>
             </a:r>
           </a:p>
         </p:txBody>
@@ -7614,7 +7614,7 @@
                   <a:srgbClr val="0B1220"/>
                 </a:solidFill>
               </a:rPr>
-              <a:t>El entorno GEMINI_API_KEY o el .env en la carpeta del proyecto</a:t>
+              <a:t>El entorno GEMINI_API_KEY / NIM_API_KEY, o el .env del proyecto o de junto al .exe</a:t>
             </a:r>
           </a:p>
         </p:txBody>
@@ -7770,7 +7770,7 @@
                   <a:srgbClr val="2A2E39"/>
                 </a:solidFill>
               </a:rPr>
-              <a:t>Cambiarla desde la bandeja (Configurar clave API…) la hace efectiva al instante, sin reiniciar.</a:t>
+              <a:t>Cambiarla desde la bandeja (Clave API Gemini… / NVIDIA…) la hace efectiva al instante, sin reiniciar.</a:t>
             </a:r>
           </a:p>
         </p:txBody>

</xml_diff>

<commit_message>
feat(variantes): implementacion completa ciclo de alternativas
ai.py: prompt_variante() + parametro evitando en CorrectorIA. estado.py: MAX_VARIANTES=2, puede_ciclar/varianles_agotadas/texto_original, conteo encadenado. engine.py: run_once + correct aceptan evitando/original_a_corregir. main.py: accion_corregir detecta ciclo y pasa evitando. bandajia.py: ya estaba en el commit anterior. Tests: test_variantes.py (prompt, fallback, variante igual no pisa) y estados en test_estado. Manual PPTX actualizado.
</commit_message>
<xml_diff>
--- a/docs/manual-g360-textofix.pptx
+++ b/docs/manual-g360-textofix.pptx
@@ -6126,7 +6126,7 @@
                   <a:srgbClr val="0B1220"/>
                 </a:solidFill>
               </a:rPr>
-              <a:t>Iniciar con Windows</a:t>
+              <a:t>Modelo de correccion</a:t>
             </a:r>
           </a:p>
         </p:txBody>
@@ -6160,7 +6160,7 @@
                   <a:srgbClr val="2A2E39"/>
                 </a:solidFill>
               </a:rPr>
-              <a:t>Registra en HKCU, solo para tu cuenta.</a:t>
+              <a:t>Auto / NVIDIA 90b / Gemini, al instante y sin reiniciar.</a:t>
             </a:r>
           </a:p>
         </p:txBody>
@@ -6282,7 +6282,7 @@
                   <a:srgbClr val="0B1220"/>
                 </a:solidFill>
               </a:rPr>
-              <a:t>Salir</a:t>
+              <a:t>Iniciar con Windows</a:t>
             </a:r>
           </a:p>
         </p:txBody>
@@ -6316,6 +6316,162 @@
                   <a:srgbClr val="2A2E39"/>
                 </a:solidFill>
               </a:rPr>
+              <a:t>Registra en HKCU, solo para tu cuenta.</a:t>
+            </a:r>
+          </a:p>
+        </p:txBody>
+      </p:sp>
+      <p:sp>
+        <p:nvSpPr>
+          <p:cNvPr id="30" name="Rectangle 29"/>
+          <p:cNvSpPr/>
+          <p:nvPr/>
+        </p:nvSpPr>
+        <p:spPr>
+          <a:xfrm>
+            <a:off x="548640" y="5961888"/>
+            <a:ext cx="11064240" cy="685800"/>
+          </a:xfrm>
+          <a:prstGeom prst="rect">
+            <a:avLst/>
+          </a:prstGeom>
+          <a:solidFill>
+            <a:srgbClr val="E9ECF2"/>
+          </a:solidFill>
+          <a:ln>
+            <a:noFill/>
+          </a:ln>
+          <a:effectLst/>
+        </p:spPr>
+        <p:style>
+          <a:lnRef idx="1">
+            <a:schemeClr val="accent1"/>
+          </a:lnRef>
+          <a:fillRef idx="3">
+            <a:schemeClr val="accent1"/>
+          </a:fillRef>
+          <a:effectRef idx="2">
+            <a:schemeClr val="accent1"/>
+          </a:effectRef>
+          <a:fontRef idx="minor">
+            <a:schemeClr val="lt1"/>
+          </a:fontRef>
+        </p:style>
+        <p:txBody>
+          <a:bodyPr rtlCol="0" anchor="ctr"/>
+          <a:lstStyle/>
+          <a:p>
+            <a:pPr algn="ctr"/>
+          </a:p>
+        </p:txBody>
+      </p:sp>
+      <p:sp>
+        <p:nvSpPr>
+          <p:cNvPr id="31" name="Rectangle 30"/>
+          <p:cNvSpPr/>
+          <p:nvPr/>
+        </p:nvSpPr>
+        <p:spPr>
+          <a:xfrm>
+            <a:off x="548640" y="5961888"/>
+            <a:ext cx="109728" cy="685800"/>
+          </a:xfrm>
+          <a:prstGeom prst="rect">
+            <a:avLst/>
+          </a:prstGeom>
+          <a:solidFill>
+            <a:srgbClr val="00D084"/>
+          </a:solidFill>
+          <a:ln>
+            <a:noFill/>
+          </a:ln>
+          <a:effectLst/>
+        </p:spPr>
+        <p:style>
+          <a:lnRef idx="1">
+            <a:schemeClr val="accent1"/>
+          </a:lnRef>
+          <a:fillRef idx="3">
+            <a:schemeClr val="accent1"/>
+          </a:fillRef>
+          <a:effectRef idx="2">
+            <a:schemeClr val="accent1"/>
+          </a:effectRef>
+          <a:fontRef idx="minor">
+            <a:schemeClr val="lt1"/>
+          </a:fontRef>
+        </p:style>
+        <p:txBody>
+          <a:bodyPr rtlCol="0" anchor="ctr"/>
+          <a:lstStyle/>
+          <a:p>
+            <a:pPr algn="ctr"/>
+          </a:p>
+        </p:txBody>
+      </p:sp>
+      <p:sp>
+        <p:nvSpPr>
+          <p:cNvPr id="32" name="TextBox 31"/>
+          <p:cNvSpPr txBox="1"/>
+          <p:nvPr/>
+        </p:nvSpPr>
+        <p:spPr>
+          <a:xfrm>
+            <a:off x="822960" y="6016752"/>
+            <a:ext cx="4114800" cy="457200"/>
+          </a:xfrm>
+          <a:prstGeom prst="rect">
+            <a:avLst/>
+          </a:prstGeom>
+          <a:noFill/>
+        </p:spPr>
+        <p:txBody>
+          <a:bodyPr wrap="square">
+            <a:spAutoFit/>
+          </a:bodyPr>
+          <a:lstStyle/>
+          <a:p>
+            <a:pPr algn="l"/>
+            <a:r>
+              <a:rPr sz="1600" b="1">
+                <a:solidFill>
+                  <a:srgbClr val="0B1220"/>
+                </a:solidFill>
+              </a:rPr>
+              <a:t>Salir</a:t>
+            </a:r>
+          </a:p>
+        </p:txBody>
+      </p:sp>
+      <p:sp>
+        <p:nvSpPr>
+          <p:cNvPr id="33" name="TextBox 32"/>
+          <p:cNvSpPr txBox="1"/>
+          <p:nvPr/>
+        </p:nvSpPr>
+        <p:spPr>
+          <a:xfrm>
+            <a:off x="5029200" y="6016752"/>
+            <a:ext cx="6492240" cy="457200"/>
+          </a:xfrm>
+          <a:prstGeom prst="rect">
+            <a:avLst/>
+          </a:prstGeom>
+          <a:noFill/>
+        </p:spPr>
+        <p:txBody>
+          <a:bodyPr wrap="square">
+            <a:spAutoFit/>
+          </a:bodyPr>
+          <a:lstStyle/>
+          <a:p>
+            <a:pPr algn="l"/>
+            <a:r>
+              <a:rPr sz="1300" b="0">
+                <a:solidFill>
+                  <a:srgbClr val="2A2E39"/>
+                </a:solidFill>
+              </a:rPr>
               <a:t>Suelta los atajos y cierra la bandeja.</a:t>
             </a:r>
           </a:p>
@@ -6323,7 +6479,7 @@
       </p:sp>
       <p:sp>
         <p:nvSpPr>
-          <p:cNvPr id="30" name="TextBox 29"/>
+          <p:cNvPr id="34" name="TextBox 33"/>
           <p:cNvSpPr txBox="1"/>
           <p:nvPr/>
         </p:nvSpPr>

</xml_diff>